<commit_message>
refactor: modularize architecture into src package and clean root directory
</commit_message>
<xml_diff>
--- a/reports/Bluestock_MF_Presentation.pptx
+++ b/reports/Bluestock_MF_Presentation.pptx
@@ -3150,44 +3150,8 @@
         </p:nvSpPr>
         <p:spPr>
           <a:xfrm>
-            <a:off x="1097280" y="1645920"/>
-            <a:ext cx="10058400" cy="457200"/>
-          </a:xfrm>
-          <a:prstGeom prst="rect">
-            <a:avLst/>
-          </a:prstGeom>
-          <a:noFill/>
-        </p:spPr>
-        <p:txBody>
-          <a:bodyPr wrap="none">
-            <a:spAutoFit/>
-          </a:bodyPr>
-          <a:lstStyle/>
-          <a:p>
-            <a:pPr>
-              <a:defRPr sz="1300" b="1">
-                <a:solidFill>
-                  <a:srgbClr val="90CDF4"/>
-                </a:solidFill>
-                <a:latin typeface="Calibri"/>
-              </a:defRPr>
-            </a:pPr>
-            <a:r>
-              <a:t>BLUESTOCK FINTECH  •  DATA ANALYST INTERNSHIP CAPSTONE</a:t>
-            </a:r>
-          </a:p>
-        </p:txBody>
-      </p:sp>
-      <p:sp>
-        <p:nvSpPr>
-          <p:cNvPr id="4" name="TextBox 3"/>
-          <p:cNvSpPr txBox="1"/>
-          <p:nvPr/>
-        </p:nvSpPr>
-        <p:spPr>
-          <a:xfrm>
-            <a:off x="1097280" y="2103120"/>
-            <a:ext cx="10058400" cy="1463040"/>
+            <a:off x="1097280" y="1828800"/>
+            <a:ext cx="10058400" cy="2743200"/>
           </a:xfrm>
           <a:prstGeom prst="rect">
             <a:avLst/>
@@ -3201,143 +3165,41 @@
           <a:lstStyle/>
           <a:p>
             <a:pPr>
-              <a:defRPr sz="4000" b="1">
+              <a:defRPr b="1" sz="1300">
+                <a:solidFill>
+                  <a:srgbClr val="90CDF4"/>
+                </a:solidFill>
+              </a:defRPr>
+            </a:pPr>
+            <a:r>
+              <a:t>BLUESTOCK FINTECH  •  DATA ANALYST INTERNSHIP CAPSTONE</a:t>
+            </a:r>
+          </a:p>
+          <a:p>
+            <a:pPr>
+              <a:defRPr b="1" sz="4000">
                 <a:solidFill>
                   <a:srgbClr val="FFFFFF"/>
                 </a:solidFill>
-                <a:latin typeface="Calibri"/>
               </a:defRPr>
             </a:pPr>
             <a:r>
               <a:t>Mutual Fund Analytics Platform</a:t>
             </a:r>
           </a:p>
-        </p:txBody>
-      </p:sp>
-      <p:sp>
-        <p:nvSpPr>
-          <p:cNvPr id="5" name="TextBox 4"/>
-          <p:cNvSpPr txBox="1"/>
-          <p:nvPr/>
-        </p:nvSpPr>
-        <p:spPr>
-          <a:xfrm>
-            <a:off x="1097280" y="3566160"/>
-            <a:ext cx="9601200" cy="822960"/>
-          </a:xfrm>
-          <a:prstGeom prst="rect">
-            <a:avLst/>
-          </a:prstGeom>
-          <a:noFill/>
-        </p:spPr>
-        <p:txBody>
-          <a:bodyPr wrap="square">
-            <a:spAutoFit/>
-          </a:bodyPr>
-          <a:lstStyle/>
-          <a:p>
-            <a:pPr>
+          <a:p>
+            <a:pPr>
+              <a:spcBef>
+                <a:spcPts val="800"/>
+              </a:spcBef>
               <a:defRPr sz="1600">
                 <a:solidFill>
                   <a:srgbClr val="E2E8F0"/>
                 </a:solidFill>
-                <a:latin typeface="Calibri"/>
               </a:defRPr>
             </a:pPr>
             <a:r>
               <a:t>End-to-End Data Engineering, Quantitative Risk Modeling, and Interactive BI Dashboard Architecture</a:t>
-            </a:r>
-          </a:p>
-        </p:txBody>
-      </p:sp>
-      <p:sp>
-        <p:nvSpPr>
-          <p:cNvPr id="6" name="Rounded Rectangle 5"/>
-          <p:cNvSpPr/>
-          <p:nvPr/>
-        </p:nvSpPr>
-        <p:spPr>
-          <a:xfrm>
-            <a:off x="1097280" y="4754880"/>
-            <a:ext cx="9966960" cy="1188720"/>
-          </a:xfrm>
-          <a:prstGeom prst="roundRect">
-            <a:avLst/>
-          </a:prstGeom>
-          <a:solidFill>
-            <a:srgbClr val="1E406E"/>
-          </a:solidFill>
-          <a:ln w="12700">
-            <a:solidFill>
-              <a:srgbClr val="3182CE"/>
-            </a:solidFill>
-          </a:ln>
-        </p:spPr>
-        <p:style>
-          <a:lnRef idx="1">
-            <a:schemeClr val="accent1"/>
-          </a:lnRef>
-          <a:fillRef idx="3">
-            <a:schemeClr val="accent1"/>
-          </a:fillRef>
-          <a:effectRef idx="2">
-            <a:schemeClr val="accent1"/>
-          </a:effectRef>
-          <a:fontRef idx="minor">
-            <a:schemeClr val="lt1"/>
-          </a:fontRef>
-        </p:style>
-        <p:txBody>
-          <a:bodyPr rtlCol="0" anchor="ctr"/>
-          <a:lstStyle/>
-          <a:p>
-            <a:pPr algn="ctr"/>
-          </a:p>
-        </p:txBody>
-      </p:sp>
-      <p:sp>
-        <p:nvSpPr>
-          <p:cNvPr id="7" name="TextBox 6"/>
-          <p:cNvSpPr txBox="1"/>
-          <p:nvPr/>
-        </p:nvSpPr>
-        <p:spPr>
-          <a:xfrm>
-            <a:off x="1280160" y="4846320"/>
-            <a:ext cx="9601200" cy="1005840"/>
-          </a:xfrm>
-          <a:prstGeom prst="rect">
-            <a:avLst/>
-          </a:prstGeom>
-          <a:noFill/>
-        </p:spPr>
-        <p:txBody>
-          <a:bodyPr wrap="none">
-            <a:spAutoFit/>
-          </a:bodyPr>
-          <a:lstStyle/>
-          <a:p>
-            <a:pPr>
-              <a:defRPr b="1" sz="1300">
-                <a:solidFill>
-                  <a:srgbClr val="FFFFFF"/>
-                </a:solidFill>
-              </a:defRPr>
-            </a:pPr>
-            <a:r>
-              <a:t>Project Scope: 40 Real Schemes  |  10 Datasets (87K+ Rows)  |  SQLite Star Schema  |  Power BI / Python</a:t>
-            </a:r>
-          </a:p>
-          <a:p>
-            <a:pPr>
-              <a:defRPr sz="1200">
-                <a:solidFill>
-                  <a:srgbClr val="BEE3F8"/>
-                </a:solidFill>
-              </a:defRPr>
-            </a:pPr>
-            <a:r>
-              <a:t>Author: Manju Angadi  •  Date: June 2026  •  Capstone Submission (Final v1.0)</a:t>
             </a:r>
           </a:p>
         </p:txBody>
@@ -3456,9 +3318,33 @@
           </a:prstGeom>
         </p:spPr>
       </p:pic>
-      <p:sp>
-        <p:nvSpPr>
-          <p:cNvPr id="5" name="Rounded Rectangle 4"/>
+      <p:pic>
+        <p:nvPicPr>
+          <p:cNvPr id="5" name="Picture 4" descr="page4_mockup.png"/>
+          <p:cNvPicPr>
+            <a:picLocks noChangeAspect="1"/>
+          </p:cNvPicPr>
+          <p:nvPr/>
+        </p:nvPicPr>
+        <p:blipFill>
+          <a:blip r:embed="rId3"/>
+          <a:stretch>
+            <a:fillRect/>
+          </a:stretch>
+        </p:blipFill>
+        <p:spPr>
+          <a:xfrm>
+            <a:off x="6309360" y="1463040"/>
+            <a:ext cx="5120640" cy="2858032"/>
+          </a:xfrm>
+          <a:prstGeom prst="rect">
+            <a:avLst/>
+          </a:prstGeom>
+        </p:spPr>
+      </p:pic>
+      <p:sp>
+        <p:nvSpPr>
+          <p:cNvPr id="6" name="Rounded Rectangle 5"/>
           <p:cNvSpPr/>
           <p:nvPr/>
         </p:nvSpPr>
@@ -3503,7 +3389,7 @@
       </p:sp>
       <p:sp>
         <p:nvSpPr>
-          <p:cNvPr id="6" name="TextBox 5"/>
+          <p:cNvPr id="7" name="TextBox 6"/>
           <p:cNvSpPr txBox="1"/>
           <p:nvPr/>
         </p:nvSpPr>
@@ -3524,54 +3410,14 @@
           <a:lstStyle/>
           <a:p>
             <a:pPr>
-              <a:defRPr b="1" sz="1200">
-                <a:solidFill>
-                  <a:srgbClr val="1A365D"/>
-                </a:solidFill>
-              </a:defRPr>
-            </a:pPr>
-            <a:r>
-              <a:t>Page 3: Investor Analytics</a:t>
-            </a:r>
-          </a:p>
-          <a:p>
-            <a:pPr>
-              <a:defRPr sz="950">
-                <a:solidFill>
-                  <a:srgbClr val="2D3748"/>
-                </a:solidFill>
-              </a:defRPr>
-            </a:pPr>
-            <a:r>
-              <a:t>State-wise capital allocation, SIP vs. Lumpsum vs. Redemption donut breakdown, age-group ticket size distribution, and monthly transaction volumes.</a:t>
-            </a:r>
-          </a:p>
-        </p:txBody>
-      </p:sp>
-      <p:pic>
-        <p:nvPicPr>
-          <p:cNvPr id="7" name="Picture 6" descr="page4_mockup.png"/>
-          <p:cNvPicPr>
-            <a:picLocks noChangeAspect="1"/>
-          </p:cNvPicPr>
-          <p:nvPr/>
-        </p:nvPicPr>
-        <p:blipFill>
-          <a:blip r:embed="rId3"/>
-          <a:stretch>
-            <a:fillRect/>
-          </a:stretch>
-        </p:blipFill>
-        <p:spPr>
-          <a:xfrm>
-            <a:off x="6309360" y="1463040"/>
-            <a:ext cx="5120640" cy="2858032"/>
-          </a:xfrm>
-          <a:prstGeom prst="rect">
-            <a:avLst/>
-          </a:prstGeom>
-        </p:spPr>
-      </p:pic>
+              <a:defRPr sz="1000"/>
+            </a:pPr>
+            <a:r>
+              <a:t>Page 3: Investor Analytics (State flows, SIP vs Lumpsum donut, Age split)</a:t>
+            </a:r>
+          </a:p>
+        </p:txBody>
+      </p:sp>
       <p:sp>
         <p:nvSpPr>
           <p:cNvPr id="8" name="Rounded Rectangle 7"/>
@@ -3640,26 +3486,10 @@
           <a:lstStyle/>
           <a:p>
             <a:pPr>
-              <a:defRPr b="1" sz="1200">
-                <a:solidFill>
-                  <a:srgbClr val="1A365D"/>
-                </a:solidFill>
-              </a:defRPr>
-            </a:pPr>
-            <a:r>
-              <a:t>Page 4: SIP &amp; Market Trends</a:t>
-            </a:r>
-          </a:p>
-          <a:p>
-            <a:pPr>
-              <a:defRPr sz="950">
-                <a:solidFill>
-                  <a:srgbClr val="2D3748"/>
-                </a:solidFill>
-              </a:defRPr>
-            </a:pPr>
-            <a:r>
-              <a:t>Dual-axis chart correlating monthly SIP inflows with Nifty 50 closing level, category net flow heatmap, and top 5 inflow leader rankings.</a:t>
+              <a:defRPr sz="1000"/>
+            </a:pPr>
+            <a:r>
+              <a:t>Page 4: SIP &amp; Market Trends (Dual axis SIP vs Nifty 50, Net category heatmap)</a:t>
             </a:r>
           </a:p>
         </p:txBody>
@@ -3763,7 +3593,7 @@
         <p:spPr>
           <a:xfrm>
             <a:off x="731520" y="1463040"/>
-            <a:ext cx="10698480" cy="1097280"/>
+            <a:ext cx="10698480" cy="4846320"/>
           </a:xfrm>
           <a:prstGeom prst="roundRect">
             <a:avLst/>
@@ -3807,8 +3637,8 @@
         </p:nvSpPr>
         <p:spPr>
           <a:xfrm>
-            <a:off x="914400" y="1554480"/>
-            <a:ext cx="10332720" cy="914400"/>
+            <a:off x="914400" y="1645920"/>
+            <a:ext cx="10332720" cy="4480560"/>
           </a:xfrm>
           <a:prstGeom prst="rect">
             <a:avLst/>
@@ -3822,20 +3652,20 @@
           <a:lstStyle/>
           <a:p>
             <a:pPr>
-              <a:defRPr b="1" sz="1300">
+              <a:defRPr b="1" sz="1500">
                 <a:solidFill>
                   <a:srgbClr val="1A365D"/>
                 </a:solidFill>
               </a:defRPr>
             </a:pPr>
             <a:r>
-              <a:t>1. Automated SIP Pre-Debit Retention Nudges</a:t>
+              <a:t>5 Strategic Action Items for Executive Leadership</a:t>
             </a:r>
           </a:p>
           <a:p>
             <a:pPr>
               <a:spcBef>
-                <a:spcPts val="300"/>
+                <a:spcPts val="800"/>
               </a:spcBef>
               <a:defRPr sz="1050">
                 <a:solidFill>
@@ -3844,93 +3674,13 @@
               </a:defRPr>
             </a:pPr>
             <a:r>
-              <a:t>With 97.8% of regular SIP investors exhibiting cadence gaps &gt; 35 days (mean 64.9 days), implement WhatsApp/SMS balance reminders 48h prior to debit dates to prevent mandate churn and bank drop-offs.</a:t>
-            </a:r>
-          </a:p>
-        </p:txBody>
-      </p:sp>
-      <p:sp>
-        <p:nvSpPr>
-          <p:cNvPr id="6" name="Rounded Rectangle 5"/>
-          <p:cNvSpPr/>
-          <p:nvPr/>
-        </p:nvSpPr>
-        <p:spPr>
-          <a:xfrm>
-            <a:off x="731520" y="2697480"/>
-            <a:ext cx="10698480" cy="1097280"/>
-          </a:xfrm>
-          <a:prstGeom prst="roundRect">
-            <a:avLst/>
-          </a:prstGeom>
-          <a:solidFill>
-            <a:srgbClr val="F8FAFC"/>
-          </a:solidFill>
-          <a:ln w="12700">
-            <a:solidFill>
-              <a:srgbClr val="E2E8F0"/>
-            </a:solidFill>
-          </a:ln>
-        </p:spPr>
-        <p:style>
-          <a:lnRef idx="1">
-            <a:schemeClr val="accent1"/>
-          </a:lnRef>
-          <a:fillRef idx="3">
-            <a:schemeClr val="accent1"/>
-          </a:fillRef>
-          <a:effectRef idx="2">
-            <a:schemeClr val="accent1"/>
-          </a:effectRef>
-          <a:fontRef idx="minor">
-            <a:schemeClr val="lt1"/>
-          </a:fontRef>
-        </p:style>
-        <p:txBody>
-          <a:bodyPr rtlCol="0" anchor="ctr"/>
-          <a:lstStyle/>
-          <a:p>
-            <a:pPr algn="ctr"/>
-          </a:p>
-        </p:txBody>
-      </p:sp>
-      <p:sp>
-        <p:nvSpPr>
-          <p:cNvPr id="7" name="TextBox 6"/>
-          <p:cNvSpPr txBox="1"/>
-          <p:nvPr/>
-        </p:nvSpPr>
-        <p:spPr>
-          <a:xfrm>
-            <a:off x="914400" y="2788920"/>
-            <a:ext cx="10332720" cy="914400"/>
-          </a:xfrm>
-          <a:prstGeom prst="rect">
-            <a:avLst/>
-          </a:prstGeom>
-          <a:noFill/>
-        </p:spPr>
-        <p:txBody>
-          <a:bodyPr wrap="square">
-            <a:spAutoFit/>
-          </a:bodyPr>
-          <a:lstStyle/>
-          <a:p>
-            <a:pPr>
-              <a:defRPr b="1" sz="1300">
-                <a:solidFill>
-                  <a:srgbClr val="1A365D"/>
-                </a:solidFill>
-              </a:defRPr>
-            </a:pPr>
-            <a:r>
-              <a:t>2. Multi-Metric Fund Scorecard Integration</a:t>
+              <a:t>• 1. Automated SIP Pre-Debit Reminders: Prevent mandate churn (97.8% at-risk cadence gaps) via WhatsApp/SMS alerts 48h prior.</a:t>
             </a:r>
           </a:p>
           <a:p>
             <a:pPr>
               <a:spcBef>
-                <a:spcPts val="300"/>
+                <a:spcPts val="800"/>
               </a:spcBef>
               <a:defRPr sz="1050">
                 <a:solidFill>
@@ -3939,93 +3689,13 @@
               </a:defRPr>
             </a:pPr>
             <a:r>
-              <a:t>Replace simple 1-year trailing return leaderboards in the retail app with our composite Scorecard (Return + Sharpe + Alpha + Expense + Drawdown) to prevent retail capital chasing past peak cyclical returns.</a:t>
-            </a:r>
-          </a:p>
-        </p:txBody>
-      </p:sp>
-      <p:sp>
-        <p:nvSpPr>
-          <p:cNvPr id="8" name="Rounded Rectangle 7"/>
-          <p:cNvSpPr/>
-          <p:nvPr/>
-        </p:nvSpPr>
-        <p:spPr>
-          <a:xfrm>
-            <a:off x="731520" y="3931920"/>
-            <a:ext cx="10698480" cy="1097280"/>
-          </a:xfrm>
-          <a:prstGeom prst="roundRect">
-            <a:avLst/>
-          </a:prstGeom>
-          <a:solidFill>
-            <a:srgbClr val="F8FAFC"/>
-          </a:solidFill>
-          <a:ln w="12700">
-            <a:solidFill>
-              <a:srgbClr val="E2E8F0"/>
-            </a:solidFill>
-          </a:ln>
-        </p:spPr>
-        <p:style>
-          <a:lnRef idx="1">
-            <a:schemeClr val="accent1"/>
-          </a:lnRef>
-          <a:fillRef idx="3">
-            <a:schemeClr val="accent1"/>
-          </a:fillRef>
-          <a:effectRef idx="2">
-            <a:schemeClr val="accent1"/>
-          </a:effectRef>
-          <a:fontRef idx="minor">
-            <a:schemeClr val="lt1"/>
-          </a:fontRef>
-        </p:style>
-        <p:txBody>
-          <a:bodyPr rtlCol="0" anchor="ctr"/>
-          <a:lstStyle/>
-          <a:p>
-            <a:pPr algn="ctr"/>
-          </a:p>
-        </p:txBody>
-      </p:sp>
-      <p:sp>
-        <p:nvSpPr>
-          <p:cNvPr id="9" name="TextBox 8"/>
-          <p:cNvSpPr txBox="1"/>
-          <p:nvPr/>
-        </p:nvSpPr>
-        <p:spPr>
-          <a:xfrm>
-            <a:off x="914400" y="4023360"/>
-            <a:ext cx="10332720" cy="914400"/>
-          </a:xfrm>
-          <a:prstGeom prst="rect">
-            <a:avLst/>
-          </a:prstGeom>
-          <a:noFill/>
-        </p:spPr>
-        <p:txBody>
-          <a:bodyPr wrap="square">
-            <a:spAutoFit/>
-          </a:bodyPr>
-          <a:lstStyle/>
-          <a:p>
-            <a:pPr>
-              <a:defRPr b="1" sz="1300">
-                <a:solidFill>
-                  <a:srgbClr val="1A365D"/>
-                </a:solidFill>
-              </a:defRPr>
-            </a:pPr>
-            <a:r>
-              <a:t>3. Tail-Risk (VaR) Warnings for Small Cap Funds</a:t>
+              <a:t>• 2. Multi-Factor Scorecard in Client App: Replace simple 1-year leaderboards with our composite 0–100 Scorecard to curb cyclical chasing.</a:t>
             </a:r>
           </a:p>
           <a:p>
             <a:pPr>
               <a:spcBef>
-                <a:spcPts val="300"/>
+                <a:spcPts val="800"/>
               </a:spcBef>
               <a:defRPr sz="1050">
                 <a:solidFill>
@@ -4034,93 +3704,13 @@
               </a:defRPr>
             </a:pPr>
             <a:r>
-              <a:t>Small-cap schemes carry daily VaR of -2.69% and CVaR exceeding -3.24%. Embed automated risk disclosure popups to set realistic expectations for first-time retail investors.</a:t>
-            </a:r>
-          </a:p>
-        </p:txBody>
-      </p:sp>
-      <p:sp>
-        <p:nvSpPr>
-          <p:cNvPr id="10" name="Rounded Rectangle 9"/>
-          <p:cNvSpPr/>
-          <p:nvPr/>
-        </p:nvSpPr>
-        <p:spPr>
-          <a:xfrm>
-            <a:off x="731520" y="5166360"/>
-            <a:ext cx="10698480" cy="1097280"/>
-          </a:xfrm>
-          <a:prstGeom prst="roundRect">
-            <a:avLst/>
-          </a:prstGeom>
-          <a:solidFill>
-            <a:srgbClr val="F8FAFC"/>
-          </a:solidFill>
-          <a:ln w="12700">
-            <a:solidFill>
-              <a:srgbClr val="E2E8F0"/>
-            </a:solidFill>
-          </a:ln>
-        </p:spPr>
-        <p:style>
-          <a:lnRef idx="1">
-            <a:schemeClr val="accent1"/>
-          </a:lnRef>
-          <a:fillRef idx="3">
-            <a:schemeClr val="accent1"/>
-          </a:fillRef>
-          <a:effectRef idx="2">
-            <a:schemeClr val="accent1"/>
-          </a:effectRef>
-          <a:fontRef idx="minor">
-            <a:schemeClr val="lt1"/>
-          </a:fontRef>
-        </p:style>
-        <p:txBody>
-          <a:bodyPr rtlCol="0" anchor="ctr"/>
-          <a:lstStyle/>
-          <a:p>
-            <a:pPr algn="ctr"/>
-          </a:p>
-        </p:txBody>
-      </p:sp>
-      <p:sp>
-        <p:nvSpPr>
-          <p:cNvPr id="11" name="TextBox 10"/>
-          <p:cNvSpPr txBox="1"/>
-          <p:nvPr/>
-        </p:nvSpPr>
-        <p:spPr>
-          <a:xfrm>
-            <a:off x="914400" y="5257800"/>
-            <a:ext cx="10332720" cy="914400"/>
-          </a:xfrm>
-          <a:prstGeom prst="rect">
-            <a:avLst/>
-          </a:prstGeom>
-          <a:noFill/>
-        </p:spPr>
-        <p:txBody>
-          <a:bodyPr wrap="square">
-            <a:spAutoFit/>
-          </a:bodyPr>
-          <a:lstStyle/>
-          <a:p>
-            <a:pPr>
-              <a:defRPr b="1" sz="1300">
-                <a:solidFill>
-                  <a:srgbClr val="1A365D"/>
-                </a:solidFill>
-              </a:defRPr>
-            </a:pPr>
-            <a:r>
-              <a:t>4. Sector Concentration Guardrails (HHI &gt; 2500)</a:t>
+              <a:t>• 3. Small-Cap Tail-Risk (VaR) Disclosures: Display annualized downside risk gauges before retail investors allocate to high-beta schemes.</a:t>
             </a:r>
           </a:p>
           <a:p>
             <a:pPr>
               <a:spcBef>
-                <a:spcPts val="300"/>
+                <a:spcPts val="800"/>
               </a:spcBef>
               <a:defRPr sz="1050">
                 <a:solidFill>
@@ -4129,7 +3719,22 @@
               </a:defRPr>
             </a:pPr>
             <a:r>
-              <a:t>Flag mutual funds exhibiting high sector concentration (e.g. Axis Bluechip at 48.7% IT). Offer automated portfolio rebalancing suggestions to safeguard retail portfolios from idiosyncratic industry shocks.</a:t>
+              <a:t>• 4. Automated Sector Concentration Alerts: Warn users when portfolios have HHI &gt; 2500 (e.g. 48.7% IT) and provide diversification swaps.</a:t>
+            </a:r>
+          </a:p>
+          <a:p>
+            <a:pPr>
+              <a:spcBef>
+                <a:spcPts val="800"/>
+              </a:spcBef>
+              <a:defRPr sz="1050">
+                <a:solidFill>
+                  <a:srgbClr val="2D3748"/>
+                </a:solidFill>
+              </a:defRPr>
+            </a:pPr>
+            <a:r>
+              <a:t>• 5. Capitalize on Cohort 2025 Purchasing Power: Target young professionals with higher initial ticket sizes (+22.8%) via curated baskets.</a:t>
             </a:r>
           </a:p>
         </p:txBody>
@@ -4203,8 +3808,8 @@
         </p:nvSpPr>
         <p:spPr>
           <a:xfrm>
-            <a:off x="1371600" y="1828800"/>
-            <a:ext cx="9418320" cy="2011680"/>
+            <a:off x="1371600" y="2011680"/>
+            <a:ext cx="9418320" cy="2743200"/>
           </a:xfrm>
           <a:prstGeom prst="rect">
             <a:avLst/>
@@ -4241,105 +3846,6 @@
             </a:pPr>
             <a:r>
               <a:t>Bluestock Mutual Fund Analytics Capstone Project Complete</a:t>
-            </a:r>
-          </a:p>
-        </p:txBody>
-      </p:sp>
-      <p:sp>
-        <p:nvSpPr>
-          <p:cNvPr id="4" name="Rounded Rectangle 3"/>
-          <p:cNvSpPr/>
-          <p:nvPr/>
-        </p:nvSpPr>
-        <p:spPr>
-          <a:xfrm>
-            <a:off x="1371600" y="4114800"/>
-            <a:ext cx="9418320" cy="1645920"/>
-          </a:xfrm>
-          <a:prstGeom prst="roundRect">
-            <a:avLst/>
-          </a:prstGeom>
-          <a:solidFill>
-            <a:srgbClr val="1E406E"/>
-          </a:solidFill>
-          <a:ln w="12700">
-            <a:solidFill>
-              <a:srgbClr val="3182CE"/>
-            </a:solidFill>
-          </a:ln>
-        </p:spPr>
-        <p:style>
-          <a:lnRef idx="1">
-            <a:schemeClr val="accent1"/>
-          </a:lnRef>
-          <a:fillRef idx="3">
-            <a:schemeClr val="accent1"/>
-          </a:fillRef>
-          <a:effectRef idx="2">
-            <a:schemeClr val="accent1"/>
-          </a:effectRef>
-          <a:fontRef idx="minor">
-            <a:schemeClr val="lt1"/>
-          </a:fontRef>
-        </p:style>
-        <p:txBody>
-          <a:bodyPr rtlCol="0" anchor="ctr"/>
-          <a:lstStyle/>
-          <a:p>
-            <a:pPr algn="ctr"/>
-          </a:p>
-        </p:txBody>
-      </p:sp>
-      <p:sp>
-        <p:nvSpPr>
-          <p:cNvPr id="5" name="TextBox 4"/>
-          <p:cNvSpPr txBox="1"/>
-          <p:nvPr/>
-        </p:nvSpPr>
-        <p:spPr>
-          <a:xfrm>
-            <a:off x="1645920" y="4297680"/>
-            <a:ext cx="8869680" cy="1280160"/>
-          </a:xfrm>
-          <a:prstGeom prst="rect">
-            <a:avLst/>
-          </a:prstGeom>
-          <a:noFill/>
-        </p:spPr>
-        <p:txBody>
-          <a:bodyPr wrap="none">
-            <a:spAutoFit/>
-          </a:bodyPr>
-          <a:lstStyle/>
-          <a:p>
-            <a:pPr>
-              <a:defRPr b="1" sz="1300">
-                <a:solidFill>
-                  <a:srgbClr val="FFFFFF"/>
-                </a:solidFill>
-              </a:defRPr>
-            </a:pPr>
-            <a:r>
-              <a:t>All Deliverables Successfully Implemented &amp; Verified:</a:t>
-            </a:r>
-          </a:p>
-          <a:p>
-            <a:pPr>
-              <a:spcBef>
-                <a:spcPts val="400"/>
-              </a:spcBef>
-              <a:defRPr sz="1100">
-                <a:solidFill>
-                  <a:srgbClr val="E2E8F0"/>
-                </a:solidFill>
-              </a:defRPr>
-            </a:pPr>
-            <a:r>
-              <a:t>• 10 Cleaned Datasets  • SQLite Database (Star Schema)  • EDA &amp; Performance Notebooks</a:t>
-            </a:r>
-            <a:br/>
-            <a:r>
-              <a:t>• 4-Page Power BI Dashboard  • 15–20 Page Final Report PDF  • Quantitative Risk Engine</a:t>
             </a:r>
           </a:p>
         </p:txBody>
@@ -4481,111 +3987,7 @@
       </p:sp>
       <p:sp>
         <p:nvSpPr>
-          <p:cNvPr id="5" name="TextBox 4"/>
-          <p:cNvSpPr txBox="1"/>
-          <p:nvPr/>
-        </p:nvSpPr>
-        <p:spPr>
-          <a:xfrm>
-            <a:off x="914400" y="1645920"/>
-            <a:ext cx="4754880" cy="4480560"/>
-          </a:xfrm>
-          <a:prstGeom prst="rect">
-            <a:avLst/>
-          </a:prstGeom>
-          <a:noFill/>
-        </p:spPr>
-        <p:txBody>
-          <a:bodyPr wrap="square">
-            <a:spAutoFit/>
-          </a:bodyPr>
-          <a:lstStyle/>
-          <a:p>
-            <a:pPr>
-              <a:defRPr sz="1600" b="1">
-                <a:solidFill>
-                  <a:srgbClr val="1A365D"/>
-                </a:solidFill>
-              </a:defRPr>
-            </a:pPr>
-            <a:r>
-              <a:t>The Retail Investment Dilemma</a:t>
-            </a:r>
-          </a:p>
-          <a:p>
-            <a:pPr>
-              <a:spcBef>
-                <a:spcPts val="1200"/>
-              </a:spcBef>
-            </a:pPr>
-            <a:r>
-              <a:rPr b="1">
-                <a:solidFill>
-                  <a:srgbClr val="3182CE"/>
-                </a:solidFill>
-              </a:rPr>
-              <a:t>• Data Fragmentation: </a:t>
-            </a:r>
-            <a:r>
-              <a:rPr>
-                <a:solidFill>
-                  <a:srgbClr val="2D3748"/>
-                </a:solidFill>
-              </a:rPr>
-              <a:t>NAV, AUM, folio counts, and transaction flows are scattered across AMFI, SEBI, and disparate exchange portals in TXT, HTML, and CSV formats.</a:t>
-            </a:r>
-          </a:p>
-          <a:p>
-            <a:pPr>
-              <a:spcBef>
-                <a:spcPts val="1200"/>
-              </a:spcBef>
-            </a:pPr>
-            <a:r>
-              <a:rPr b="1">
-                <a:solidFill>
-                  <a:srgbClr val="3182CE"/>
-                </a:solidFill>
-              </a:rPr>
-              <a:t>• Lack of Unified Analytics: </a:t>
-            </a:r>
-            <a:r>
-              <a:rPr>
-                <a:solidFill>
-                  <a:srgbClr val="2D3748"/>
-                </a:solidFill>
-              </a:rPr>
-              <a:t>Retail investors struggle to assess true risk-adjusted performance, often misjudging high trailing returns without evaluating downside volatility.</a:t>
-            </a:r>
-          </a:p>
-          <a:p>
-            <a:pPr>
-              <a:spcBef>
-                <a:spcPts val="1200"/>
-              </a:spcBef>
-            </a:pPr>
-            <a:r>
-              <a:rPr b="1">
-                <a:solidFill>
-                  <a:srgbClr val="3182CE"/>
-                </a:solidFill>
-              </a:rPr>
-              <a:t>• SIP Friction &amp; Drop-Offs: </a:t>
-            </a:r>
-            <a:r>
-              <a:rPr>
-                <a:solidFill>
-                  <a:srgbClr val="2D3748"/>
-                </a:solidFill>
-              </a:rPr>
-              <a:t>High initial investor excitement is plagued by mandate skips, bank balance defaults, and lack of automated cadenced retention tracking.</a:t>
-            </a:r>
-          </a:p>
-        </p:txBody>
-      </p:sp>
-      <p:sp>
-        <p:nvSpPr>
-          <p:cNvPr id="6" name="Rounded Rectangle 5"/>
+          <p:cNvPr id="5" name="Rounded Rectangle 4"/>
           <p:cNvSpPr/>
           <p:nvPr/>
         </p:nvSpPr>
@@ -4630,6 +4032,110 @@
       </p:sp>
       <p:sp>
         <p:nvSpPr>
+          <p:cNvPr id="6" name="TextBox 5"/>
+          <p:cNvSpPr txBox="1"/>
+          <p:nvPr/>
+        </p:nvSpPr>
+        <p:spPr>
+          <a:xfrm>
+            <a:off x="914400" y="1645920"/>
+            <a:ext cx="4754880" cy="4480560"/>
+          </a:xfrm>
+          <a:prstGeom prst="rect">
+            <a:avLst/>
+          </a:prstGeom>
+          <a:noFill/>
+        </p:spPr>
+        <p:txBody>
+          <a:bodyPr wrap="square">
+            <a:spAutoFit/>
+          </a:bodyPr>
+          <a:lstStyle/>
+          <a:p>
+            <a:pPr>
+              <a:defRPr b="1" sz="1600">
+                <a:solidFill>
+                  <a:srgbClr val="1A365D"/>
+                </a:solidFill>
+              </a:defRPr>
+            </a:pPr>
+            <a:r>
+              <a:t>The Retail Investment Dilemma</a:t>
+            </a:r>
+          </a:p>
+          <a:p>
+            <a:pPr>
+              <a:spcBef>
+                <a:spcPts val="1200"/>
+              </a:spcBef>
+            </a:pPr>
+            <a:r>
+              <a:rPr b="1">
+                <a:solidFill>
+                  <a:srgbClr val="3182CE"/>
+                </a:solidFill>
+              </a:rPr>
+              <a:t>• Data Fragmentation: </a:t>
+            </a:r>
+            <a:r>
+              <a:rPr>
+                <a:solidFill>
+                  <a:srgbClr val="2D3748"/>
+                </a:solidFill>
+              </a:rPr>
+              <a:t>Scattered datasets across AMFI, exchanges, and SEBI portals.</a:t>
+            </a:r>
+          </a:p>
+          <a:p>
+            <a:pPr>
+              <a:spcBef>
+                <a:spcPts val="1200"/>
+              </a:spcBef>
+            </a:pPr>
+            <a:r>
+              <a:rPr b="1">
+                <a:solidFill>
+                  <a:srgbClr val="3182CE"/>
+                </a:solidFill>
+              </a:rPr>
+              <a:t>• Recency Bias: </a:t>
+            </a:r>
+            <a:r>
+              <a:rPr>
+                <a:solidFill>
+                  <a:srgbClr val="2D3748"/>
+                </a:solidFill>
+              </a:rPr>
+              <a:t>Chasing trailing returns without factoring downside tail volatility.</a:t>
+            </a:r>
+          </a:p>
+          <a:p>
+            <a:pPr>
+              <a:spcBef>
+                <a:spcPts val="1200"/>
+              </a:spcBef>
+            </a:pPr>
+            <a:r>
+              <a:rPr b="1">
+                <a:solidFill>
+                  <a:srgbClr val="3182CE"/>
+                </a:solidFill>
+              </a:rPr>
+              <a:t>• SIP Friction: </a:t>
+            </a:r>
+            <a:r>
+              <a:rPr>
+                <a:solidFill>
+                  <a:srgbClr val="2D3748"/>
+                </a:solidFill>
+              </a:rPr>
+              <a:t>Mandate drop-offs and irregular cadence hampering compounding.</a:t>
+            </a:r>
+          </a:p>
+        </p:txBody>
+      </p:sp>
+      <p:sp>
+        <p:nvSpPr>
           <p:cNvPr id="7" name="TextBox 6"/>
           <p:cNvSpPr txBox="1"/>
           <p:nvPr/>
@@ -4651,7 +4157,7 @@
           <a:lstStyle/>
           <a:p>
             <a:pPr>
-              <a:defRPr sz="1600" b="1">
+              <a:defRPr b="1" sz="1600">
                 <a:solidFill>
                   <a:srgbClr val="1A365D"/>
                 </a:solidFill>
@@ -4673,7 +4179,7 @@
                   <a:srgbClr val="38A169"/>
                 </a:solidFill>
               </a:rPr>
-              <a:t>✔ Automated ETL Pipeline: </a:t>
+              <a:t>[OK] Automated ETL Pipeline: </a:t>
             </a:r>
             <a:r>
               <a:rPr>
@@ -4681,7 +4187,7 @@
                   <a:srgbClr val="2D3748"/>
                 </a:solidFill>
               </a:rPr>
-              <a:t>Ingest, clean, and validate 10 relational datasets with automated live NAV integration via mfapi.in.</a:t>
+              <a:t>Ingest, clean, and validate 10 relational tables.</a:t>
             </a:r>
           </a:p>
           <a:p>
@@ -4696,7 +4202,7 @@
                   <a:srgbClr val="38A169"/>
                 </a:solidFill>
               </a:rPr>
-              <a:t>✔ Relational Star Schema: </a:t>
+              <a:t>[OK] Relational Star Schema: </a:t>
             </a:r>
             <a:r>
               <a:rPr>
@@ -4704,7 +4210,7 @@
                   <a:srgbClr val="2D3748"/>
                 </a:solidFill>
               </a:rPr>
-              <a:t>Architect a high-performance SQLite data warehouse linking dimension and fact tables for fast BI querying.</a:t>
+              <a:t>SQLite warehouse optimized for fast BI queries.</a:t>
             </a:r>
           </a:p>
           <a:p>
@@ -4719,7 +4225,7 @@
                   <a:srgbClr val="38A169"/>
                 </a:solidFill>
               </a:rPr>
-              <a:t>✔ Quantitative Risk Modeling: </a:t>
+              <a:t>[OK] Quantitative Risk Modeling: </a:t>
             </a:r>
             <a:r>
               <a:rPr>
@@ -4727,7 +4233,7 @@
                   <a:srgbClr val="2D3748"/>
                 </a:solidFill>
               </a:rPr>
-              <a:t>Compute CAGR, Sharpe, Sortino, Alpha, Beta, Max Drawdown, 95% Historical VaR/CVaR, and Sector HHI.</a:t>
+              <a:t>VaR 95%, CVaR, Rolling Sharpe, and Sector HHI.</a:t>
             </a:r>
           </a:p>
           <a:p>
@@ -4742,7 +4248,7 @@
                   <a:srgbClr val="38A169"/>
                 </a:solidFill>
               </a:rPr>
-              <a:t>✔ Interactive BI Dashboard: </a:t>
+              <a:t>[OK] Interactive BI Dashboard: </a:t>
             </a:r>
             <a:r>
               <a:rPr>
@@ -4750,7 +4256,7 @@
                   <a:srgbClr val="2D3748"/>
                 </a:solidFill>
               </a:rPr>
-              <a:t>Design 4 visual pages in Power BI with drill-through navigation, category slicers, and executive KPI cards.</a:t>
+              <a:t>4-page layout with slicers and KPI tracking.</a:t>
             </a:r>
           </a:p>
         </p:txBody>
@@ -4854,7 +4360,7 @@
         <p:spPr>
           <a:xfrm>
             <a:off x="731520" y="1463040"/>
-            <a:ext cx="3291840" cy="2011680"/>
+            <a:ext cx="10698480" cy="4846320"/>
           </a:xfrm>
           <a:prstGeom prst="roundRect">
             <a:avLst/>
@@ -4899,7 +4405,7 @@
         <p:spPr>
           <a:xfrm>
             <a:off x="914400" y="1645920"/>
-            <a:ext cx="2926080" cy="1645920"/>
+            <a:ext cx="10332720" cy="4480560"/>
           </a:xfrm>
           <a:prstGeom prst="rect">
             <a:avLst/>
@@ -4913,482 +4419,104 @@
           <a:lstStyle/>
           <a:p>
             <a:pPr>
-              <a:defRPr b="1" sz="1400">
+              <a:defRPr b="1" sz="1500">
                 <a:solidFill>
                   <a:srgbClr val="1A365D"/>
                 </a:solidFill>
               </a:defRPr>
             </a:pPr>
             <a:r>
-              <a:t>Public Data Sources</a:t>
+              <a:t>10 Public Datasets Analyzed (87,000+ Records)</a:t>
             </a:r>
           </a:p>
           <a:p>
             <a:pPr>
               <a:spcBef>
-                <a:spcPts val="400"/>
+                <a:spcPts val="800"/>
               </a:spcBef>
-              <a:defRPr b="1" sz="1100">
-                <a:solidFill>
-                  <a:srgbClr val="3182CE"/>
-                </a:solidFill>
-              </a:defRPr>
-            </a:pPr>
-            <a:r>
-              <a:t>AMFI India, mfapi.in, NSE/BSE</a:t>
+              <a:defRPr sz="1100">
+                <a:solidFill>
+                  <a:srgbClr val="2D3748"/>
+                </a:solidFill>
+              </a:defRPr>
+            </a:pPr>
+            <a:r>
+              <a:t>• 01_fund_master.csv (40 Schemes, Expense ratios, Benchmarks, SEBI risk tiers)</a:t>
             </a:r>
           </a:p>
           <a:p>
             <a:pPr>
               <a:spcBef>
-                <a:spcPts val="600"/>
+                <a:spcPts val="800"/>
               </a:spcBef>
-              <a:defRPr sz="1000">
+              <a:defRPr sz="1100">
                 <a:solidFill>
                   <a:srgbClr val="2D3748"/>
                 </a:solidFill>
               </a:defRPr>
             </a:pPr>
             <a:r>
-              <a:t>Aggregates real scheme NAVs, benchmark indices (Nifty 50, Nifty 100), and monthly industry flows without private credentials.</a:t>
-            </a:r>
-          </a:p>
-        </p:txBody>
-      </p:sp>
-      <p:sp>
-        <p:nvSpPr>
-          <p:cNvPr id="6" name="Rounded Rectangle 5"/>
-          <p:cNvSpPr/>
-          <p:nvPr/>
-        </p:nvSpPr>
-        <p:spPr>
-          <a:xfrm>
-            <a:off x="4434840" y="1463040"/>
-            <a:ext cx="3291840" cy="2011680"/>
-          </a:xfrm>
-          <a:prstGeom prst="roundRect">
-            <a:avLst/>
-          </a:prstGeom>
-          <a:solidFill>
-            <a:srgbClr val="F8FAFC"/>
-          </a:solidFill>
-          <a:ln w="12700">
-            <a:solidFill>
-              <a:srgbClr val="E2E8F0"/>
-            </a:solidFill>
-          </a:ln>
-        </p:spPr>
-        <p:style>
-          <a:lnRef idx="1">
-            <a:schemeClr val="accent1"/>
-          </a:lnRef>
-          <a:fillRef idx="3">
-            <a:schemeClr val="accent1"/>
-          </a:fillRef>
-          <a:effectRef idx="2">
-            <a:schemeClr val="accent1"/>
-          </a:effectRef>
-          <a:fontRef idx="minor">
-            <a:schemeClr val="lt1"/>
-          </a:fontRef>
-        </p:style>
-        <p:txBody>
-          <a:bodyPr rtlCol="0" anchor="ctr"/>
-          <a:lstStyle/>
-          <a:p>
-            <a:pPr algn="ctr"/>
-          </a:p>
-        </p:txBody>
-      </p:sp>
-      <p:sp>
-        <p:nvSpPr>
-          <p:cNvPr id="7" name="TextBox 6"/>
-          <p:cNvSpPr txBox="1"/>
-          <p:nvPr/>
-        </p:nvSpPr>
-        <p:spPr>
-          <a:xfrm>
-            <a:off x="4617720" y="1645920"/>
-            <a:ext cx="2926080" cy="1645920"/>
-          </a:xfrm>
-          <a:prstGeom prst="rect">
-            <a:avLst/>
-          </a:prstGeom>
-          <a:noFill/>
-        </p:spPr>
-        <p:txBody>
-          <a:bodyPr wrap="square">
-            <a:spAutoFit/>
-          </a:bodyPr>
-          <a:lstStyle/>
-          <a:p>
-            <a:pPr>
-              <a:defRPr b="1" sz="1400">
-                <a:solidFill>
-                  <a:srgbClr val="1A365D"/>
-                </a:solidFill>
-              </a:defRPr>
-            </a:pPr>
-            <a:r>
-              <a:t>Dataset Scale</a:t>
+              <a:t>• 02_nav_history.csv (43,000+ daily NAV records spanning 2022–2026)</a:t>
             </a:r>
           </a:p>
           <a:p>
             <a:pPr>
               <a:spcBef>
-                <a:spcPts val="400"/>
+                <a:spcPts val="800"/>
               </a:spcBef>
-              <a:defRPr b="1" sz="1100">
-                <a:solidFill>
-                  <a:srgbClr val="3182CE"/>
-                </a:solidFill>
-              </a:defRPr>
-            </a:pPr>
-            <a:r>
-              <a:t>10 Tables  |  87,000+ Rows</a:t>
+              <a:defRPr sz="1100">
+                <a:solidFill>
+                  <a:srgbClr val="2D3748"/>
+                </a:solidFill>
+              </a:defRPr>
+            </a:pPr>
+            <a:r>
+              <a:t>• 07_scheme_performance.csv (1Y/3Y/5Y CAGR, Sharpe, Sortino, Alpha, Beta, Max DD)</a:t>
             </a:r>
           </a:p>
           <a:p>
             <a:pPr>
               <a:spcBef>
-                <a:spcPts val="600"/>
+                <a:spcPts val="800"/>
               </a:spcBef>
-              <a:defRPr sz="1000">
+              <a:defRPr sz="1100">
                 <a:solidFill>
                   <a:srgbClr val="2D3748"/>
                 </a:solidFill>
               </a:defRPr>
             </a:pPr>
             <a:r>
-              <a:t>Covers 40 real schemes, 32,000+ investor transactions, 320 portfolio holdings, and multi-year daily NAV timelines.</a:t>
-            </a:r>
-          </a:p>
-        </p:txBody>
-      </p:sp>
-      <p:sp>
-        <p:nvSpPr>
-          <p:cNvPr id="8" name="Rounded Rectangle 7"/>
-          <p:cNvSpPr/>
-          <p:nvPr/>
-        </p:nvSpPr>
-        <p:spPr>
-          <a:xfrm>
-            <a:off x="8138160" y="1463040"/>
-            <a:ext cx="3291840" cy="2011680"/>
-          </a:xfrm>
-          <a:prstGeom prst="roundRect">
-            <a:avLst/>
-          </a:prstGeom>
-          <a:solidFill>
-            <a:srgbClr val="F8FAFC"/>
-          </a:solidFill>
-          <a:ln w="12700">
-            <a:solidFill>
-              <a:srgbClr val="E2E8F0"/>
-            </a:solidFill>
-          </a:ln>
-        </p:spPr>
-        <p:style>
-          <a:lnRef idx="1">
-            <a:schemeClr val="accent1"/>
-          </a:lnRef>
-          <a:fillRef idx="3">
-            <a:schemeClr val="accent1"/>
-          </a:fillRef>
-          <a:effectRef idx="2">
-            <a:schemeClr val="accent1"/>
-          </a:effectRef>
-          <a:fontRef idx="minor">
-            <a:schemeClr val="lt1"/>
-          </a:fontRef>
-        </p:style>
-        <p:txBody>
-          <a:bodyPr rtlCol="0" anchor="ctr"/>
-          <a:lstStyle/>
-          <a:p>
-            <a:pPr algn="ctr"/>
-          </a:p>
-        </p:txBody>
-      </p:sp>
-      <p:sp>
-        <p:nvSpPr>
-          <p:cNvPr id="9" name="TextBox 8"/>
-          <p:cNvSpPr txBox="1"/>
-          <p:nvPr/>
-        </p:nvSpPr>
-        <p:spPr>
-          <a:xfrm>
-            <a:off x="8321040" y="1645920"/>
-            <a:ext cx="2926080" cy="1645920"/>
-          </a:xfrm>
-          <a:prstGeom prst="rect">
-            <a:avLst/>
-          </a:prstGeom>
-          <a:noFill/>
-        </p:spPr>
-        <p:txBody>
-          <a:bodyPr wrap="square">
-            <a:spAutoFit/>
-          </a:bodyPr>
-          <a:lstStyle/>
-          <a:p>
-            <a:pPr>
-              <a:defRPr b="1" sz="1400">
-                <a:solidFill>
-                  <a:srgbClr val="1A365D"/>
-                </a:solidFill>
-              </a:defRPr>
-            </a:pPr>
-            <a:r>
-              <a:t>Validation &amp; Quality</a:t>
+              <a:t>• 08_investor_transactions.csv (32,778 SIP and Lumpsum transaction records)</a:t>
             </a:r>
           </a:p>
           <a:p>
             <a:pPr>
               <a:spcBef>
-                <a:spcPts val="400"/>
+                <a:spcPts val="800"/>
               </a:spcBef>
-              <a:defRPr b="1" sz="1100">
-                <a:solidFill>
-                  <a:srgbClr val="3182CE"/>
-                </a:solidFill>
-              </a:defRPr>
-            </a:pPr>
-            <a:r>
-              <a:t>100% Schema Validation</a:t>
+              <a:defRPr sz="1100">
+                <a:solidFill>
+                  <a:srgbClr val="2D3748"/>
+                </a:solidFill>
+              </a:defRPr>
+            </a:pPr>
+            <a:r>
+              <a:t>• 09_portfolio_holdings.csv (320 equity holdings across sectors)</a:t>
             </a:r>
           </a:p>
           <a:p>
             <a:pPr>
               <a:spcBef>
-                <a:spcPts val="600"/>
+                <a:spcPts val="800"/>
               </a:spcBef>
-              <a:defRPr sz="1000">
+              <a:defRPr sz="1100">
                 <a:solidFill>
                   <a:srgbClr val="2D3748"/>
                 </a:solidFill>
               </a:defRPr>
             </a:pPr>
             <a:r>
-              <a:t>Forward-fills weekend gaps, enforces strict positive NAV constraints, removes duplicates, and flags synthetic anomalies.</a:t>
-            </a:r>
-          </a:p>
-        </p:txBody>
-      </p:sp>
-      <p:sp>
-        <p:nvSpPr>
-          <p:cNvPr id="10" name="Rounded Rectangle 9"/>
-          <p:cNvSpPr/>
-          <p:nvPr/>
-        </p:nvSpPr>
-        <p:spPr>
-          <a:xfrm>
-            <a:off x="731520" y="3749039"/>
-            <a:ext cx="10698480" cy="2560320"/>
-          </a:xfrm>
-          <a:prstGeom prst="roundRect">
-            <a:avLst/>
-          </a:prstGeom>
-          <a:solidFill>
-            <a:srgbClr val="F8FAFC"/>
-          </a:solidFill>
-          <a:ln w="12700">
-            <a:solidFill>
-              <a:srgbClr val="E2E8F0"/>
-            </a:solidFill>
-          </a:ln>
-        </p:spPr>
-        <p:style>
-          <a:lnRef idx="1">
-            <a:schemeClr val="accent1"/>
-          </a:lnRef>
-          <a:fillRef idx="3">
-            <a:schemeClr val="accent1"/>
-          </a:fillRef>
-          <a:effectRef idx="2">
-            <a:schemeClr val="accent1"/>
-          </a:effectRef>
-          <a:fontRef idx="minor">
-            <a:schemeClr val="lt1"/>
-          </a:fontRef>
-        </p:style>
-        <p:txBody>
-          <a:bodyPr rtlCol="0" anchor="ctr"/>
-          <a:lstStyle/>
-          <a:p>
-            <a:pPr algn="ctr"/>
-          </a:p>
-        </p:txBody>
-      </p:sp>
-      <p:sp>
-        <p:nvSpPr>
-          <p:cNvPr id="11" name="TextBox 10"/>
-          <p:cNvSpPr txBox="1"/>
-          <p:nvPr/>
-        </p:nvSpPr>
-        <p:spPr>
-          <a:xfrm>
-            <a:off x="914400" y="3840480"/>
-            <a:ext cx="10332720" cy="2286000"/>
-          </a:xfrm>
-          <a:prstGeom prst="rect">
-            <a:avLst/>
-          </a:prstGeom>
-          <a:noFill/>
-        </p:spPr>
-        <p:txBody>
-          <a:bodyPr wrap="square">
-            <a:spAutoFit/>
-          </a:bodyPr>
-          <a:lstStyle/>
-          <a:p>
-            <a:pPr>
-              <a:defRPr b="1" sz="1300">
-                <a:solidFill>
-                  <a:srgbClr val="1A365D"/>
-                </a:solidFill>
-              </a:defRPr>
-            </a:pPr>
-            <a:r>
-              <a:t>Dataset Catalog &amp; Mapping</a:t>
-            </a:r>
-          </a:p>
-          <a:p>
-            <a:pPr>
-              <a:spcBef>
-                <a:spcPts val="400"/>
-              </a:spcBef>
-            </a:pPr>
-            <a:r>
-              <a:rPr b="1" sz="1000">
-                <a:solidFill>
-                  <a:srgbClr val="3182CE"/>
-                </a:solidFill>
-              </a:rPr>
-              <a:t>• 01_fund_master.csv (40 Schemes): </a:t>
-            </a:r>
-            <a:r>
-              <a:rPr sz="1000">
-                <a:solidFill>
-                  <a:srgbClr val="2D3748"/>
-                </a:solidFill>
-              </a:rPr>
-              <a:t>amfi_code, fund_house, scheme_name, category, benchmark, expense_ratio, risk_grade</a:t>
-            </a:r>
-          </a:p>
-          <a:p>
-            <a:pPr>
-              <a:spcBef>
-                <a:spcPts val="400"/>
-              </a:spcBef>
-            </a:pPr>
-            <a:r>
-              <a:rPr b="1" sz="1000">
-                <a:solidFill>
-                  <a:srgbClr val="3182CE"/>
-                </a:solidFill>
-              </a:rPr>
-              <a:t>• 02_nav_history.csv (43,000+ Rows): </a:t>
-            </a:r>
-            <a:r>
-              <a:rPr sz="1000">
-                <a:solidFill>
-                  <a:srgbClr val="2D3748"/>
-                </a:solidFill>
-              </a:rPr>
-              <a:t>amfi_code, date, nav (Historical daily NAV series 2022–2026)</a:t>
-            </a:r>
-          </a:p>
-          <a:p>
-            <a:pPr>
-              <a:spcBef>
-                <a:spcPts val="400"/>
-              </a:spcBef>
-            </a:pPr>
-            <a:r>
-              <a:rPr b="1" sz="1000">
-                <a:solidFill>
-                  <a:srgbClr val="3182CE"/>
-                </a:solidFill>
-              </a:rPr>
-              <a:t>• 07_scheme_performance.csv (40 Schemes): </a:t>
-            </a:r>
-            <a:r>
-              <a:rPr sz="1000">
-                <a:solidFill>
-                  <a:srgbClr val="2D3748"/>
-                </a:solidFill>
-              </a:rPr>
-              <a:t>1Y/3Y/5Y CAGR, Alpha, Beta, Sharpe, Sortino, Max Drawdown, Volatility</a:t>
-            </a:r>
-          </a:p>
-          <a:p>
-            <a:pPr>
-              <a:spcBef>
-                <a:spcPts val="400"/>
-              </a:spcBef>
-            </a:pPr>
-            <a:r>
-              <a:rPr b="1" sz="1000">
-                <a:solidFill>
-                  <a:srgbClr val="3182CE"/>
-                </a:solidFill>
-              </a:rPr>
-              <a:t>• 08_investor_transactions.csv (32,778 Rows): </a:t>
-            </a:r>
-            <a:r>
-              <a:rPr sz="1000">
-                <a:solidFill>
-                  <a:srgbClr val="2D3748"/>
-                </a:solidFill>
-              </a:rPr>
-              <a:t>investor_id, date, amfi_code, type (SIP/Lumpsum/Redemption), amount, state, age, tier</a:t>
-            </a:r>
-          </a:p>
-          <a:p>
-            <a:pPr>
-              <a:spcBef>
-                <a:spcPts val="400"/>
-              </a:spcBef>
-            </a:pPr>
-            <a:r>
-              <a:rPr b="1" sz="1000">
-                <a:solidFill>
-                  <a:srgbClr val="3182CE"/>
-                </a:solidFill>
-              </a:rPr>
-              <a:t>• 09_portfolio_holdings.csv (320 Holdings): </a:t>
-            </a:r>
-            <a:r>
-              <a:rPr sz="1000">
-                <a:solidFill>
-                  <a:srgbClr val="2D3748"/>
-                </a:solidFill>
-              </a:rPr>
-              <a:t>amfi_code, stock_symbol, sector, weight_pct, market_value_cr</a:t>
-            </a:r>
-          </a:p>
-          <a:p>
-            <a:pPr>
-              <a:spcBef>
-                <a:spcPts val="400"/>
-              </a:spcBef>
-            </a:pPr>
-            <a:r>
-              <a:rPr b="1" sz="1000">
-                <a:solidFill>
-                  <a:srgbClr val="3182CE"/>
-                </a:solidFill>
-              </a:rPr>
-              <a:t>• 10_benchmark_indices.csv (8,000+ Rows): </a:t>
-            </a:r>
-            <a:r>
-              <a:rPr sz="1000">
-                <a:solidFill>
-                  <a:srgbClr val="2D3748"/>
-                </a:solidFill>
-              </a:rPr>
-              <a:t>date, nifty_50, nifty_100, nifty_midcap_150, bse_smallcap, crisil_liquid</a:t>
+              <a:t>• 10_benchmark_indices.csv (8,000+ daily benchmark closing levels: NIFTY 50, NIFTY 100)</a:t>
             </a:r>
           </a:p>
         </p:txBody>
@@ -5492,7 +4620,7 @@
         <p:spPr>
           <a:xfrm>
             <a:off x="731520" y="1463040"/>
-            <a:ext cx="2377440" cy="1828800"/>
+            <a:ext cx="10698480" cy="4846320"/>
           </a:xfrm>
           <a:prstGeom prst="roundRect">
             <a:avLst/>
@@ -5536,8 +4664,8 @@
         </p:nvSpPr>
         <p:spPr>
           <a:xfrm>
-            <a:off x="868680" y="1600200"/>
-            <a:ext cx="2103120" cy="1554480"/>
+            <a:off x="914400" y="1645920"/>
+            <a:ext cx="10332720" cy="4480560"/>
           </a:xfrm>
           <a:prstGeom prst="rect">
             <a:avLst/>
@@ -5551,546 +4679,74 @@
           <a:lstStyle/>
           <a:p>
             <a:pPr>
-              <a:defRPr b="1" sz="1200">
+              <a:defRPr b="1" sz="1500">
                 <a:solidFill>
                   <a:srgbClr val="1A365D"/>
                 </a:solidFill>
               </a:defRPr>
             </a:pPr>
             <a:r>
-              <a:t>1. Data Ingestion</a:t>
+              <a:t>Star Schema Architecture (bluestock_mf.db)</a:t>
             </a:r>
           </a:p>
           <a:p>
             <a:pPr>
               <a:spcBef>
-                <a:spcPts val="300"/>
+                <a:spcPts val="800"/>
               </a:spcBef>
-              <a:defRPr b="1" sz="1000">
-                <a:solidFill>
-                  <a:srgbClr val="3182CE"/>
-                </a:solidFill>
-              </a:defRPr>
-            </a:pPr>
-            <a:r>
-              <a:t>Fetch &amp; Load</a:t>
+              <a:defRPr sz="1100">
+                <a:solidFill>
+                  <a:srgbClr val="2D3748"/>
+                </a:solidFill>
+              </a:defRPr>
+            </a:pPr>
+            <a:r>
+              <a:t>• dim_fund [amfi_code] (1-to-many) filters fact_nav, fact_performance, fact_transactions</a:t>
             </a:r>
           </a:p>
           <a:p>
             <a:pPr>
               <a:spcBef>
-                <a:spcPts val="400"/>
+                <a:spcPts val="800"/>
               </a:spcBef>
-              <a:defRPr sz="950">
+              <a:defRPr sz="1100">
                 <a:solidFill>
                   <a:srgbClr val="2D3748"/>
                 </a:solidFill>
               </a:defRPr>
             </a:pPr>
             <a:r>
-              <a:t>Extract raw CSVs and query live NAV data from mfapi.in REST API.</a:t>
-            </a:r>
-          </a:p>
-        </p:txBody>
-      </p:sp>
-      <p:sp>
-        <p:nvSpPr>
-          <p:cNvPr id="6" name="Rounded Rectangle 5"/>
-          <p:cNvSpPr/>
-          <p:nvPr/>
-        </p:nvSpPr>
-        <p:spPr>
-          <a:xfrm>
-            <a:off x="3520440" y="1463040"/>
-            <a:ext cx="2377440" cy="1828800"/>
-          </a:xfrm>
-          <a:prstGeom prst="roundRect">
-            <a:avLst/>
-          </a:prstGeom>
-          <a:solidFill>
-            <a:srgbClr val="F8FAFC"/>
-          </a:solidFill>
-          <a:ln w="12700">
-            <a:solidFill>
-              <a:srgbClr val="E2E8F0"/>
-            </a:solidFill>
-          </a:ln>
-        </p:spPr>
-        <p:style>
-          <a:lnRef idx="1">
-            <a:schemeClr val="accent1"/>
-          </a:lnRef>
-          <a:fillRef idx="3">
-            <a:schemeClr val="accent1"/>
-          </a:fillRef>
-          <a:effectRef idx="2">
-            <a:schemeClr val="accent1"/>
-          </a:effectRef>
-          <a:fontRef idx="minor">
-            <a:schemeClr val="lt1"/>
-          </a:fontRef>
-        </p:style>
-        <p:txBody>
-          <a:bodyPr rtlCol="0" anchor="ctr"/>
-          <a:lstStyle/>
-          <a:p>
-            <a:pPr algn="ctr"/>
-          </a:p>
-        </p:txBody>
-      </p:sp>
-      <p:sp>
-        <p:nvSpPr>
-          <p:cNvPr id="7" name="TextBox 6"/>
-          <p:cNvSpPr txBox="1"/>
-          <p:nvPr/>
-        </p:nvSpPr>
-        <p:spPr>
-          <a:xfrm>
-            <a:off x="3657600" y="1600200"/>
-            <a:ext cx="2103120" cy="1554480"/>
-          </a:xfrm>
-          <a:prstGeom prst="rect">
-            <a:avLst/>
-          </a:prstGeom>
-          <a:noFill/>
-        </p:spPr>
-        <p:txBody>
-          <a:bodyPr wrap="square">
-            <a:spAutoFit/>
-          </a:bodyPr>
-          <a:lstStyle/>
-          <a:p>
-            <a:pPr>
-              <a:defRPr b="1" sz="1200">
-                <a:solidFill>
-                  <a:srgbClr val="1A365D"/>
-                </a:solidFill>
-              </a:defRPr>
-            </a:pPr>
-            <a:r>
-              <a:t>2. Data Cleaning</a:t>
+              <a:t>• dim_date [date] (1-to-many) filters fact_nav, fact_transactions, benchmark_indices</a:t>
             </a:r>
           </a:p>
           <a:p>
             <a:pPr>
               <a:spcBef>
-                <a:spcPts val="300"/>
+                <a:spcPts val="800"/>
               </a:spcBef>
-              <a:defRPr b="1" sz="1000">
-                <a:solidFill>
-                  <a:srgbClr val="3182CE"/>
-                </a:solidFill>
-              </a:defRPr>
-            </a:pPr>
-            <a:r>
-              <a:t>Transform &amp; Clean</a:t>
+              <a:defRPr sz="1100">
+                <a:solidFill>
+                  <a:srgbClr val="2D3748"/>
+                </a:solidFill>
+              </a:defRPr>
+            </a:pPr>
+            <a:r>
+              <a:t>• Compound B-Tree indexing on (amfi_code, date) yields sub-15ms join latency</a:t>
             </a:r>
           </a:p>
           <a:p>
             <a:pPr>
               <a:spcBef>
-                <a:spcPts val="400"/>
+                <a:spcPts val="800"/>
               </a:spcBef>
-              <a:defRPr sz="950">
+              <a:defRPr sz="1100">
                 <a:solidFill>
                   <a:srgbClr val="2D3748"/>
                 </a:solidFill>
               </a:defRPr>
             </a:pPr>
             <a:r>
-              <a:t>Forward-fill holidays, validate constraints, and structure processed CSVs.</a:t>
-            </a:r>
-          </a:p>
-        </p:txBody>
-      </p:sp>
-      <p:sp>
-        <p:nvSpPr>
-          <p:cNvPr id="8" name="Rounded Rectangle 7"/>
-          <p:cNvSpPr/>
-          <p:nvPr/>
-        </p:nvSpPr>
-        <p:spPr>
-          <a:xfrm>
-            <a:off x="6309360" y="1463040"/>
-            <a:ext cx="2377440" cy="1828800"/>
-          </a:xfrm>
-          <a:prstGeom prst="roundRect">
-            <a:avLst/>
-          </a:prstGeom>
-          <a:solidFill>
-            <a:srgbClr val="F8FAFC"/>
-          </a:solidFill>
-          <a:ln w="12700">
-            <a:solidFill>
-              <a:srgbClr val="E2E8F0"/>
-            </a:solidFill>
-          </a:ln>
-        </p:spPr>
-        <p:style>
-          <a:lnRef idx="1">
-            <a:schemeClr val="accent1"/>
-          </a:lnRef>
-          <a:fillRef idx="3">
-            <a:schemeClr val="accent1"/>
-          </a:fillRef>
-          <a:effectRef idx="2">
-            <a:schemeClr val="accent1"/>
-          </a:effectRef>
-          <a:fontRef idx="minor">
-            <a:schemeClr val="lt1"/>
-          </a:fontRef>
-        </p:style>
-        <p:txBody>
-          <a:bodyPr rtlCol="0" anchor="ctr"/>
-          <a:lstStyle/>
-          <a:p>
-            <a:pPr algn="ctr"/>
-          </a:p>
-        </p:txBody>
-      </p:sp>
-      <p:sp>
-        <p:nvSpPr>
-          <p:cNvPr id="9" name="TextBox 8"/>
-          <p:cNvSpPr txBox="1"/>
-          <p:nvPr/>
-        </p:nvSpPr>
-        <p:spPr>
-          <a:xfrm>
-            <a:off x="6446520" y="1600200"/>
-            <a:ext cx="2103120" cy="1554480"/>
-          </a:xfrm>
-          <a:prstGeom prst="rect">
-            <a:avLst/>
-          </a:prstGeom>
-          <a:noFill/>
-        </p:spPr>
-        <p:txBody>
-          <a:bodyPr wrap="square">
-            <a:spAutoFit/>
-          </a:bodyPr>
-          <a:lstStyle/>
-          <a:p>
-            <a:pPr>
-              <a:defRPr b="1" sz="1200">
-                <a:solidFill>
-                  <a:srgbClr val="1A365D"/>
-                </a:solidFill>
-              </a:defRPr>
-            </a:pPr>
-            <a:r>
-              <a:t>3. SQLite Warehouse</a:t>
-            </a:r>
-          </a:p>
-          <a:p>
-            <a:pPr>
-              <a:spcBef>
-                <a:spcPts val="300"/>
-              </a:spcBef>
-              <a:defRPr b="1" sz="1000">
-                <a:solidFill>
-                  <a:srgbClr val="3182CE"/>
-                </a:solidFill>
-              </a:defRPr>
-            </a:pPr>
-            <a:r>
-              <a:t>Star Schema DB</a:t>
-            </a:r>
-          </a:p>
-          <a:p>
-            <a:pPr>
-              <a:spcBef>
-                <a:spcPts val="400"/>
-              </a:spcBef>
-              <a:defRPr sz="950">
-                <a:solidFill>
-                  <a:srgbClr val="2D3748"/>
-                </a:solidFill>
-              </a:defRPr>
-            </a:pPr>
-            <a:r>
-              <a:t>Load relational tables with primary/foreign keys on amfi_code and date.</a:t>
-            </a:r>
-          </a:p>
-        </p:txBody>
-      </p:sp>
-      <p:sp>
-        <p:nvSpPr>
-          <p:cNvPr id="10" name="Rounded Rectangle 9"/>
-          <p:cNvSpPr/>
-          <p:nvPr/>
-        </p:nvSpPr>
-        <p:spPr>
-          <a:xfrm>
-            <a:off x="9098280" y="1463040"/>
-            <a:ext cx="2377440" cy="1828800"/>
-          </a:xfrm>
-          <a:prstGeom prst="roundRect">
-            <a:avLst/>
-          </a:prstGeom>
-          <a:solidFill>
-            <a:srgbClr val="F8FAFC"/>
-          </a:solidFill>
-          <a:ln w="12700">
-            <a:solidFill>
-              <a:srgbClr val="E2E8F0"/>
-            </a:solidFill>
-          </a:ln>
-        </p:spPr>
-        <p:style>
-          <a:lnRef idx="1">
-            <a:schemeClr val="accent1"/>
-          </a:lnRef>
-          <a:fillRef idx="3">
-            <a:schemeClr val="accent1"/>
-          </a:fillRef>
-          <a:effectRef idx="2">
-            <a:schemeClr val="accent1"/>
-          </a:effectRef>
-          <a:fontRef idx="minor">
-            <a:schemeClr val="lt1"/>
-          </a:fontRef>
-        </p:style>
-        <p:txBody>
-          <a:bodyPr rtlCol="0" anchor="ctr"/>
-          <a:lstStyle/>
-          <a:p>
-            <a:pPr algn="ctr"/>
-          </a:p>
-        </p:txBody>
-      </p:sp>
-      <p:sp>
-        <p:nvSpPr>
-          <p:cNvPr id="11" name="TextBox 10"/>
-          <p:cNvSpPr txBox="1"/>
-          <p:nvPr/>
-        </p:nvSpPr>
-        <p:spPr>
-          <a:xfrm>
-            <a:off x="9235440" y="1600200"/>
-            <a:ext cx="2103120" cy="1554480"/>
-          </a:xfrm>
-          <a:prstGeom prst="rect">
-            <a:avLst/>
-          </a:prstGeom>
-          <a:noFill/>
-        </p:spPr>
-        <p:txBody>
-          <a:bodyPr wrap="square">
-            <a:spAutoFit/>
-          </a:bodyPr>
-          <a:lstStyle/>
-          <a:p>
-            <a:pPr>
-              <a:defRPr b="1" sz="1200">
-                <a:solidFill>
-                  <a:srgbClr val="1A365D"/>
-                </a:solidFill>
-              </a:defRPr>
-            </a:pPr>
-            <a:r>
-              <a:t>4. Analytics &amp; BI</a:t>
-            </a:r>
-          </a:p>
-          <a:p>
-            <a:pPr>
-              <a:spcBef>
-                <a:spcPts val="300"/>
-              </a:spcBef>
-              <a:defRPr b="1" sz="1000">
-                <a:solidFill>
-                  <a:srgbClr val="3182CE"/>
-                </a:solidFill>
-              </a:defRPr>
-            </a:pPr>
-            <a:r>
-              <a:t>Insights &amp; Visuals</a:t>
-            </a:r>
-          </a:p>
-          <a:p>
-            <a:pPr>
-              <a:spcBef>
-                <a:spcPts val="400"/>
-              </a:spcBef>
-              <a:defRPr sz="950">
-                <a:solidFill>
-                  <a:srgbClr val="2D3748"/>
-                </a:solidFill>
-              </a:defRPr>
-            </a:pPr>
-            <a:r>
-              <a:t>Execute risk models, scorecard ranking, and interactive Power BI pages.</a:t>
-            </a:r>
-          </a:p>
-        </p:txBody>
-      </p:sp>
-      <p:sp>
-        <p:nvSpPr>
-          <p:cNvPr id="12" name="Rounded Rectangle 11"/>
-          <p:cNvSpPr/>
-          <p:nvPr/>
-        </p:nvSpPr>
-        <p:spPr>
-          <a:xfrm>
-            <a:off x="731520" y="3566160"/>
-            <a:ext cx="10744200" cy="2743200"/>
-          </a:xfrm>
-          <a:prstGeom prst="roundRect">
-            <a:avLst/>
-          </a:prstGeom>
-          <a:solidFill>
-            <a:srgbClr val="F8FAFC"/>
-          </a:solidFill>
-          <a:ln w="12700">
-            <a:solidFill>
-              <a:srgbClr val="E2E8F0"/>
-            </a:solidFill>
-          </a:ln>
-        </p:spPr>
-        <p:style>
-          <a:lnRef idx="1">
-            <a:schemeClr val="accent1"/>
-          </a:lnRef>
-          <a:fillRef idx="3">
-            <a:schemeClr val="accent1"/>
-          </a:fillRef>
-          <a:effectRef idx="2">
-            <a:schemeClr val="accent1"/>
-          </a:effectRef>
-          <a:fontRef idx="minor">
-            <a:schemeClr val="lt1"/>
-          </a:fontRef>
-        </p:style>
-        <p:txBody>
-          <a:bodyPr rtlCol="0" anchor="ctr"/>
-          <a:lstStyle/>
-          <a:p>
-            <a:pPr algn="ctr"/>
-          </a:p>
-        </p:txBody>
-      </p:sp>
-      <p:sp>
-        <p:nvSpPr>
-          <p:cNvPr id="13" name="TextBox 12"/>
-          <p:cNvSpPr txBox="1"/>
-          <p:nvPr/>
-        </p:nvSpPr>
-        <p:spPr>
-          <a:xfrm>
-            <a:off x="914400" y="3657600"/>
-            <a:ext cx="10378440" cy="2468880"/>
-          </a:xfrm>
-          <a:prstGeom prst="rect">
-            <a:avLst/>
-          </a:prstGeom>
-          <a:noFill/>
-        </p:spPr>
-        <p:txBody>
-          <a:bodyPr wrap="square">
-            <a:spAutoFit/>
-          </a:bodyPr>
-          <a:lstStyle/>
-          <a:p>
-            <a:pPr>
-              <a:defRPr b="1" sz="1400">
-                <a:solidFill>
-                  <a:srgbClr val="1A365D"/>
-                </a:solidFill>
-              </a:defRPr>
-            </a:pPr>
-            <a:r>
-              <a:t>Star Schema Relational Design (bluestock_mf.db)</a:t>
-            </a:r>
-          </a:p>
-          <a:p>
-            <a:pPr>
-              <a:spcBef>
-                <a:spcPts val="600"/>
-              </a:spcBef>
-            </a:pPr>
-            <a:r>
-              <a:rPr b="1" sz="1050">
-                <a:solidFill>
-                  <a:srgbClr val="3182CE"/>
-                </a:solidFill>
-              </a:rPr>
-              <a:t>• Central Dimension 1 — dim_fund [amfi_code] (1-to-Many): </a:t>
-            </a:r>
-            <a:r>
-              <a:rPr sz="1050">
-                <a:solidFill>
-                  <a:srgbClr val="2D3748"/>
-                </a:solidFill>
-              </a:rPr>
-              <a:t>Filters fact_nav, fact_performance, fact_transactions, and portfolio_holdings.</a:t>
-            </a:r>
-          </a:p>
-          <a:p>
-            <a:pPr>
-              <a:spcBef>
-                <a:spcPts val="600"/>
-              </a:spcBef>
-            </a:pPr>
-            <a:r>
-              <a:rPr b="1" sz="1050">
-                <a:solidFill>
-                  <a:srgbClr val="3182CE"/>
-                </a:solidFill>
-              </a:rPr>
-              <a:t>• Central Dimension 2 — dim_date [date] (1-to-Many): </a:t>
-            </a:r>
-            <a:r>
-              <a:rPr sz="1050">
-                <a:solidFill>
-                  <a:srgbClr val="2D3748"/>
-                </a:solidFill>
-              </a:rPr>
-              <a:t>Filters daily NAV records, benchmark indices, monthly SIP inflows, and investor transactions.</a:t>
-            </a:r>
-          </a:p>
-          <a:p>
-            <a:pPr>
-              <a:spcBef>
-                <a:spcPts val="600"/>
-              </a:spcBef>
-            </a:pPr>
-            <a:r>
-              <a:rPr b="1" sz="1050">
-                <a:solidFill>
-                  <a:srgbClr val="3182CE"/>
-                </a:solidFill>
-              </a:rPr>
-              <a:t>• Fact Tables: </a:t>
-            </a:r>
-            <a:r>
-              <a:rPr sz="1050">
-                <a:solidFill>
-                  <a:srgbClr val="2D3748"/>
-                </a:solidFill>
-              </a:rPr>
-              <a:t>fact_nav (daily valuation series), fact_performance (risk &amp; return statistics), fact_transactions (32K investor records).</a:t>
-            </a:r>
-          </a:p>
-          <a:p>
-            <a:pPr>
-              <a:spcBef>
-                <a:spcPts val="600"/>
-              </a:spcBef>
-            </a:pPr>
-            <a:r>
-              <a:rPr b="1" sz="1050">
-                <a:solidFill>
-                  <a:srgbClr val="3182CE"/>
-                </a:solidFill>
-              </a:rPr>
-              <a:t>• Performance Optimizations: </a:t>
-            </a:r>
-            <a:r>
-              <a:rPr sz="1050">
-                <a:solidFill>
-                  <a:srgbClr val="2D3748"/>
-                </a:solidFill>
-              </a:rPr>
-              <a:t>B-Tree indexed on amfi_code and date; ensures sub-10ms query latency across analytical SQL aggregations.</a:t>
+              <a:t>• Zero duplicate primary keys, forward-filled weekend gaps, strict referential integrity</a:t>
             </a:r>
           </a:p>
         </p:txBody>
@@ -6226,7 +4882,7 @@
         <p:spPr>
           <a:xfrm>
             <a:off x="6309360" y="1463040"/>
-            <a:ext cx="5120640" cy="2560320"/>
+            <a:ext cx="5120640" cy="2327564"/>
           </a:xfrm>
           <a:prstGeom prst="rect">
             <a:avLst/>
@@ -6301,44 +4957,14 @@
           <a:lstStyle/>
           <a:p>
             <a:pPr>
-              <a:defRPr b="1" sz="1200">
-                <a:solidFill>
-                  <a:srgbClr val="1A365D"/>
-                </a:solidFill>
-              </a:defRPr>
-            </a:pPr>
-            <a:r>
-              <a:t>Key Macro Takeaways:</a:t>
-            </a:r>
-          </a:p>
-          <a:p>
-            <a:pPr>
-              <a:spcBef>
-                <a:spcPts val="300"/>
-              </a:spcBef>
-              <a:defRPr sz="1000">
+              <a:defRPr sz="1100">
                 <a:solidFill>
                   <a:srgbClr val="2D3748"/>
                 </a:solidFill>
               </a:defRPr>
             </a:pPr>
             <a:r>
-              <a:t>✔ Industry AUM Expansion: Exploded from ₹38 Lakh Crore in early 2022 to over ₹81 Lakh Crore by Dec 2025 (~26% CAGR).</a:t>
-            </a:r>
-          </a:p>
-          <a:p>
-            <a:pPr>
-              <a:spcBef>
-                <a:spcPts val="300"/>
-              </a:spcBef>
-              <a:defRPr sz="1000">
-                <a:solidFill>
-                  <a:srgbClr val="2D3748"/>
-                </a:solidFill>
-              </a:defRPr>
-            </a:pPr>
-            <a:r>
-              <a:t>✔ SIP Democratization: Monthly SIP contributions grew from ₹11,500 Cr to over ₹31,000 Cr, reflecting persistent retail dollar-cost averaging.</a:t>
+              <a:t>Key Takeaways: Industry AUM expanded from ₹38.2L Cr to ₹81.4L Cr (+26.3% CAGR). Monthly SIP inflows surged past ₹31,000 Cr.</a:t>
             </a:r>
           </a:p>
         </p:txBody>
@@ -6450,7 +5076,7 @@
         <p:spPr>
           <a:xfrm>
             <a:off x="731520" y="1463040"/>
-            <a:ext cx="5120640" cy="3072384"/>
+            <a:ext cx="5120640" cy="2560320"/>
           </a:xfrm>
           <a:prstGeom prst="rect">
             <a:avLst/>
@@ -6474,7 +5100,7 @@
         <p:spPr>
           <a:xfrm>
             <a:off x="6309360" y="1463040"/>
-            <a:ext cx="5120640" cy="3413760"/>
+            <a:ext cx="5120640" cy="2844800"/>
           </a:xfrm>
           <a:prstGeom prst="rect">
             <a:avLst/>
@@ -6549,44 +5175,14 @@
           <a:lstStyle/>
           <a:p>
             <a:pPr>
-              <a:defRPr b="1" sz="1200">
-                <a:solidFill>
-                  <a:srgbClr val="1A365D"/>
-                </a:solidFill>
-              </a:defRPr>
-            </a:pPr>
-            <a:r>
-              <a:t>Key Demographic Takeaways:</a:t>
-            </a:r>
-          </a:p>
-          <a:p>
-            <a:pPr>
-              <a:spcBef>
-                <a:spcPts val="300"/>
-              </a:spcBef>
-              <a:defRPr sz="1000">
+              <a:defRPr sz="1100">
                 <a:solidFill>
                   <a:srgbClr val="2D3748"/>
                 </a:solidFill>
               </a:defRPr>
             </a:pPr>
             <a:r>
-              <a:t>✔ Geographic Concentration: Maharashtra, Gujarat, and Karnataka account for over 54% of total transaction capital.</a:t>
-            </a:r>
-          </a:p>
-          <a:p>
-            <a:pPr>
-              <a:spcBef>
-                <a:spcPts val="300"/>
-              </a:spcBef>
-              <a:defRPr sz="1000">
-                <a:solidFill>
-                  <a:srgbClr val="2D3748"/>
-                </a:solidFill>
-              </a:defRPr>
-            </a:pPr>
-            <a:r>
-              <a:t>✔ Age Group Ticket Sizes: While 26–35 age group drives transaction count (fintech apps), 46–55 cohorts commit the highest median SIP amounts.</a:t>
+              <a:t>Key Takeaways: Maharashtra, Gujarat, and Karnataka drive 54% of capital. 26-35 age group leads count; 46-55 leads ticket size (₹14,200).</a:t>
             </a:r>
           </a:p>
         </p:txBody>
@@ -6788,22 +5384,14 @@
               <a:spcBef>
                 <a:spcPts val="800"/>
               </a:spcBef>
-            </a:pPr>
-            <a:r>
-              <a:rPr b="1" sz="1000">
-                <a:solidFill>
-                  <a:srgbClr val="3182CE"/>
-                </a:solidFill>
-              </a:rPr>
-              <a:t>• Multi-Factor Formula: </a:t>
-            </a:r>
-            <a:r>
-              <a:rPr sz="1000">
+              <a:defRPr sz="1050">
                 <a:solidFill>
                   <a:srgbClr val="2D3748"/>
                 </a:solidFill>
-              </a:rPr>
-              <a:t>30% 3Y Return + 25% Sharpe + 20% Alpha + 15% Low Expense + 10% Low Max DD.</a:t>
+              </a:defRPr>
+            </a:pPr>
+            <a:r>
+              <a:t>• Mirae Asset Large Cap Fund ranked #1 (Score 87.25, 3Y CAGR 14.81%, Sharpe 1.06)</a:t>
             </a:r>
           </a:p>
           <a:p>
@@ -6811,22 +5399,14 @@
               <a:spcBef>
                 <a:spcPts val="800"/>
               </a:spcBef>
-            </a:pPr>
-            <a:r>
-              <a:rPr b="1" sz="1000">
-                <a:solidFill>
-                  <a:srgbClr val="3182CE"/>
-                </a:solidFill>
-              </a:rPr>
-              <a:t>• Rank 1 — Mirae Asset Large Cap: </a:t>
-            </a:r>
-            <a:r>
-              <a:rPr sz="1000">
+              <a:defRPr sz="1050">
                 <a:solidFill>
                   <a:srgbClr val="2D3748"/>
                 </a:solidFill>
-              </a:rPr>
-              <a:t>Score 87.25 | Sharpe 1.06 | 3Y CAGR 14.81% | Steady large-cap compounder.</a:t>
+              </a:defRPr>
+            </a:pPr>
+            <a:r>
+              <a:t>• HDFC Mid-Cap Opportunities generated highest manager alpha (+27.11% vs Nifty 100)</a:t>
             </a:r>
           </a:p>
           <a:p>
@@ -6834,22 +5414,14 @@
               <a:spcBef>
                 <a:spcPts val="800"/>
               </a:spcBef>
-            </a:pPr>
-            <a:r>
-              <a:rPr b="1" sz="1000">
-                <a:solidFill>
-                  <a:srgbClr val="3182CE"/>
-                </a:solidFill>
-              </a:rPr>
-              <a:t>• Rank 2 — HDFC Mid-Cap Opportunities: </a:t>
-            </a:r>
-            <a:r>
-              <a:rPr sz="1000">
+              <a:defRPr sz="1050">
                 <a:solidFill>
                   <a:srgbClr val="2D3748"/>
                 </a:solidFill>
-              </a:rPr>
-              <a:t>Score 84.10 | Alpha +27.11% | Strong manager outperformance vs Nifty 100.</a:t>
+              </a:defRPr>
+            </a:pPr>
+            <a:r>
+              <a:t>• Kotak Flexicap ranked #3 (Score 81.50) with balanced multi-cap allocation</a:t>
             </a:r>
           </a:p>
           <a:p>
@@ -6857,45 +5429,14 @@
               <a:spcBef>
                 <a:spcPts val="800"/>
               </a:spcBef>
-            </a:pPr>
-            <a:r>
-              <a:rPr b="1" sz="1000">
-                <a:solidFill>
-                  <a:srgbClr val="3182CE"/>
-                </a:solidFill>
-              </a:rPr>
-              <a:t>• Rank 3 — Kotak Flexicap Fund: </a:t>
-            </a:r>
-            <a:r>
-              <a:rPr sz="1000">
+              <a:defRPr sz="1050">
                 <a:solidFill>
                   <a:srgbClr val="2D3748"/>
                 </a:solidFill>
-              </a:rPr>
-              <a:t>Score 81.50 | Sharpe 1.02 | Dynamic multi-cap market allocation.</a:t>
-            </a:r>
-          </a:p>
-          <a:p>
-            <a:pPr>
-              <a:spcBef>
-                <a:spcPts val="800"/>
-              </a:spcBef>
-            </a:pPr>
-            <a:r>
-              <a:rPr b="1" sz="1000">
-                <a:solidFill>
-                  <a:srgbClr val="3182CE"/>
-                </a:solidFill>
-              </a:rPr>
-              <a:t>• Expense Sensitivity: </a:t>
-            </a:r>
-            <a:r>
-              <a:rPr sz="1000">
-                <a:solidFill>
-                  <a:srgbClr val="2D3748"/>
-                </a:solidFill>
-              </a:rPr>
-              <a:t>Direct plans generate 0.8% to 1.2% higher annualized return due to zero distributor commission drag.</a:t>
+              </a:defRPr>
+            </a:pPr>
+            <a:r>
+              <a:t>• Direct plans deliver 0.75% to 1.15% annualized excess compounding vs Regular</a:t>
             </a:r>
           </a:p>
         </p:txBody>
@@ -7007,7 +5548,7 @@
         <p:spPr>
           <a:xfrm>
             <a:off x="731520" y="1463040"/>
-            <a:ext cx="5669280" cy="2834640"/>
+            <a:ext cx="5669280" cy="2598420"/>
           </a:xfrm>
           <a:prstGeom prst="rect">
             <a:avLst/>
@@ -7089,99 +5630,82 @@
               </a:defRPr>
             </a:pPr>
             <a:r>
-              <a:t>Advanced Quantitative Takeaways</a:t>
+              <a:t>Advanced Risk Insights</a:t>
             </a:r>
           </a:p>
           <a:p>
             <a:pPr>
               <a:spcBef>
-                <a:spcPts val="800"/>
+                <a:spcPts val="600"/>
               </a:spcBef>
-            </a:pPr>
-            <a:r>
-              <a:rPr b="1" sz="1000">
-                <a:solidFill>
-                  <a:srgbClr val="3182CE"/>
-                </a:solidFill>
-              </a:rPr>
-              <a:t>• Historical VaR &amp; CVaR (95%): </a:t>
-            </a:r>
-            <a:r>
-              <a:rPr sz="1000">
+              <a:defRPr sz="1000">
                 <a:solidFill>
                   <a:srgbClr val="2D3748"/>
                 </a:solidFill>
-              </a:rPr>
-              <a:t>Small cap schemes exhibit 1-day VaR of -2.69% and CVaR of -3.24% (worst 5% days), contrasting with Liquid funds at -0.03%.</a:t>
+              </a:defRPr>
+            </a:pPr>
+            <a:r>
+              <a:t>• Small Cap schemes exhibit 1-day 95% VaR of -2.69% and CVaR of -3.24% (tail loss)</a:t>
             </a:r>
           </a:p>
           <a:p>
             <a:pPr>
               <a:spcBef>
-                <a:spcPts val="800"/>
+                <a:spcPts val="600"/>
               </a:spcBef>
-            </a:pPr>
-            <a:r>
-              <a:rPr b="1" sz="1000">
-                <a:solidFill>
-                  <a:srgbClr val="3182CE"/>
-                </a:solidFill>
-              </a:rPr>
-              <a:t>• Rolling Sharpe Instability: </a:t>
-            </a:r>
-            <a:r>
-              <a:rPr sz="1000">
+              <a:defRPr sz="1000">
                 <a:solidFill>
                   <a:srgbClr val="2D3748"/>
                 </a:solidFill>
-              </a:rPr>
-              <a:t>HDFC Mid-Cap Sharpe oscillated between -0.80 and +3.20, showing that point-in-time metrics can misrepresent cyclical volatility.</a:t>
+              </a:defRPr>
+            </a:pPr>
+            <a:r>
+              <a:t>• Liquid schemes preserve capital with daily VaR of only -0.03%</a:t>
             </a:r>
           </a:p>
           <a:p>
             <a:pPr>
               <a:spcBef>
-                <a:spcPts val="800"/>
+                <a:spcPts val="600"/>
               </a:spcBef>
-            </a:pPr>
-            <a:r>
-              <a:rPr b="1" sz="1000">
-                <a:solidFill>
-                  <a:srgbClr val="3182CE"/>
-                </a:solidFill>
-              </a:rPr>
-              <a:t>• SIP Continuity &amp; Churn: </a:t>
-            </a:r>
-            <a:r>
-              <a:rPr sz="1000">
+              <a:defRPr sz="1000">
                 <a:solidFill>
                   <a:srgbClr val="2D3748"/>
                 </a:solidFill>
-              </a:rPr>
-              <a:t>97.8% of investors with 6+ SIPs have average gaps &gt; 35 days (cohort mean 64.9 days), revealing widespread mandate pauses.</a:t>
+              </a:defRPr>
+            </a:pPr>
+            <a:r>
+              <a:t>• Rolling Sharpe of HDFC Mid-Cap swung from -0.80 to +3.20 across cycles</a:t>
             </a:r>
           </a:p>
           <a:p>
             <a:pPr>
               <a:spcBef>
-                <a:spcPts val="800"/>
+                <a:spcPts val="600"/>
               </a:spcBef>
-            </a:pPr>
-            <a:r>
-              <a:rPr b="1" sz="1000">
-                <a:solidFill>
-                  <a:srgbClr val="3182CE"/>
-                </a:solidFill>
-              </a:rPr>
-              <a:t>• Sector HHI Concentration: </a:t>
-            </a:r>
-            <a:r>
-              <a:rPr sz="1000">
+              <a:defRPr sz="1000">
                 <a:solidFill>
                   <a:srgbClr val="2D3748"/>
                 </a:solidFill>
-              </a:rPr>
-              <a:t>Axis Bluechip has HHI of 2,967 (48.7% IT). Funds with HHI &gt; 2,500 carry acute single-sector vulnerability.</a:t>
+              </a:defRPr>
+            </a:pPr>
+            <a:r>
+              <a:t>• 97.8% of regular SIP investors show cadence gaps &gt; 35 days (mean 64.9 days)</a:t>
+            </a:r>
+          </a:p>
+          <a:p>
+            <a:pPr>
+              <a:spcBef>
+                <a:spcPts val="600"/>
+              </a:spcBef>
+              <a:defRPr sz="1000">
+                <a:solidFill>
+                  <a:srgbClr val="2D3748"/>
+                </a:solidFill>
+              </a:defRPr>
+            </a:pPr>
+            <a:r>
+              <a:t>• Axis Bluechip shows elevated HHI of 2,967 (48.7% IT concentration)</a:t>
             </a:r>
           </a:p>
         </p:txBody>
@@ -7300,9 +5824,33 @@
           </a:prstGeom>
         </p:spPr>
       </p:pic>
-      <p:sp>
-        <p:nvSpPr>
-          <p:cNvPr id="5" name="Rounded Rectangle 4"/>
+      <p:pic>
+        <p:nvPicPr>
+          <p:cNvPr id="5" name="Picture 4" descr="page2_mockup.png"/>
+          <p:cNvPicPr>
+            <a:picLocks noChangeAspect="1"/>
+          </p:cNvPicPr>
+          <p:nvPr/>
+        </p:nvPicPr>
+        <p:blipFill>
+          <a:blip r:embed="rId3"/>
+          <a:stretch>
+            <a:fillRect/>
+          </a:stretch>
+        </p:blipFill>
+        <p:spPr>
+          <a:xfrm>
+            <a:off x="6309360" y="1463040"/>
+            <a:ext cx="5120640" cy="2858032"/>
+          </a:xfrm>
+          <a:prstGeom prst="rect">
+            <a:avLst/>
+          </a:prstGeom>
+        </p:spPr>
+      </p:pic>
+      <p:sp>
+        <p:nvSpPr>
+          <p:cNvPr id="6" name="Rounded Rectangle 5"/>
           <p:cNvSpPr/>
           <p:nvPr/>
         </p:nvSpPr>
@@ -7347,7 +5895,7 @@
       </p:sp>
       <p:sp>
         <p:nvSpPr>
-          <p:cNvPr id="6" name="TextBox 5"/>
+          <p:cNvPr id="7" name="TextBox 6"/>
           <p:cNvSpPr txBox="1"/>
           <p:nvPr/>
         </p:nvSpPr>
@@ -7368,54 +5916,14 @@
           <a:lstStyle/>
           <a:p>
             <a:pPr>
-              <a:defRPr b="1" sz="1200">
-                <a:solidFill>
-                  <a:srgbClr val="1A365D"/>
-                </a:solidFill>
-              </a:defRPr>
-            </a:pPr>
-            <a:r>
-              <a:t>Page 1: Industry Overview</a:t>
-            </a:r>
-          </a:p>
-          <a:p>
-            <a:pPr>
-              <a:defRPr sz="950">
-                <a:solidFill>
-                  <a:srgbClr val="2D3748"/>
-                </a:solidFill>
-              </a:defRPr>
-            </a:pPr>
-            <a:r>
-              <a:t>Displays executive KPI cards (₹81L Cr AUM, ₹31K Cr SIP, 26.12 Cr Folios), multi-year AUM growth timeline, and AMC market share distribution.</a:t>
-            </a:r>
-          </a:p>
-        </p:txBody>
-      </p:sp>
-      <p:pic>
-        <p:nvPicPr>
-          <p:cNvPr id="7" name="Picture 6" descr="page2_mockup.png"/>
-          <p:cNvPicPr>
-            <a:picLocks noChangeAspect="1"/>
-          </p:cNvPicPr>
-          <p:nvPr/>
-        </p:nvPicPr>
-        <p:blipFill>
-          <a:blip r:embed="rId3"/>
-          <a:stretch>
-            <a:fillRect/>
-          </a:stretch>
-        </p:blipFill>
-        <p:spPr>
-          <a:xfrm>
-            <a:off x="6309360" y="1463040"/>
-            <a:ext cx="5120640" cy="2858032"/>
-          </a:xfrm>
-          <a:prstGeom prst="rect">
-            <a:avLst/>
-          </a:prstGeom>
-        </p:spPr>
-      </p:pic>
+              <a:defRPr sz="1000"/>
+            </a:pPr>
+            <a:r>
+              <a:t>Page 1: Industry Overview (AUM ₹81L Cr, SIP ₹31K Cr, AMC share)</a:t>
+            </a:r>
+          </a:p>
+        </p:txBody>
+      </p:sp>
       <p:sp>
         <p:nvSpPr>
           <p:cNvPr id="8" name="Rounded Rectangle 7"/>
@@ -7484,26 +5992,10 @@
           <a:lstStyle/>
           <a:p>
             <a:pPr>
-              <a:defRPr b="1" sz="1200">
-                <a:solidFill>
-                  <a:srgbClr val="1A365D"/>
-                </a:solidFill>
-              </a:defRPr>
-            </a:pPr>
-            <a:r>
-              <a:t>Page 2: Fund Performance</a:t>
-            </a:r>
-          </a:p>
-          <a:p>
-            <a:pPr>
-              <a:defRPr sz="950">
-                <a:solidFill>
-                  <a:srgbClr val="2D3748"/>
-                </a:solidFill>
-              </a:defRPr>
-            </a:pPr>
-            <a:r>
-              <a:t>Features a Risk vs. Return scatter plot (CAGR vs Volatility), interactive scorecard table, benchmark NAV line chart, and AMC/category slicers.</a:t>
+              <a:defRPr sz="1000"/>
+            </a:pPr>
+            <a:r>
+              <a:t>Page 2: Fund Performance (Return vs Risk scatter, Scorecard table, slicers)</a:t>
             </a:r>
           </a:p>
         </p:txBody>

</xml_diff>